<commit_message>
fixed case study 3
</commit_message>
<xml_diff>
--- a/figures/Figure4_case3.pptx
+++ b/figures/Figure4_case3.pptx
@@ -1559,18 +1559,6 @@
               <a:buNone/>
             </a:pPr>
             <a:r>
-              <a:rPr lang="en-CA" sz="1200" b="1">
-                <a:solidFill>
-                  <a:schemeClr val="dk1"/>
-                </a:solidFill>
-                <a:latin typeface="Arial"/>
-                <a:ea typeface="Arial"/>
-                <a:cs typeface="Arial"/>
-                <a:sym typeface="Arial"/>
-              </a:rPr>
-              <a:t>Figure 3. </a:t>
-            </a:r>
-            <a:r>
               <a:rPr lang="en-CA" sz="1200" b="1" dirty="0">
                 <a:solidFill>
                   <a:schemeClr val="dk1"/>
@@ -1580,7 +1568,7 @@
                 <a:cs typeface="Arial"/>
                 <a:sym typeface="Arial"/>
               </a:rPr>
-              <a:t>Systematic evaluation of </a:t>
+              <a:t>Figure 3. Systematic evaluation of </a:t>
             </a:r>
             <a:r>
               <a:rPr lang="en-CA" sz="1200" b="1" dirty="0" err="1">

</xml_diff>